<commit_message>
Updates to image based on STU2 ballot recon
</commit_message>
<xml_diff>
--- a/input/images-source/ccrr-ig-diagrams.pptx
+++ b/input/images-source/ccrr-ig-diagrams.pptx
@@ -206,7 +206,7 @@
           <a:p>
             <a:fld id="{AB97FB07-E237-456B-A4F0-F2C4672E0DE9}" type="datetimeFigureOut">
               <a:rPr lang="en-US" smtClean="0"/>
-              <a:t>11/6/2025</a:t>
+              <a:t>8/24/2026</a:t>
             </a:fld>
             <a:endParaRPr lang="en-US"/>
           </a:p>
@@ -2023,7 +2023,7 @@
                 <a:latin typeface="Constantia"/>
               </a:rPr>
               <a:pPr/>
-              <a:t>11/6/2025</a:t>
+              <a:t>8/24/2026</a:t>
             </a:fld>
             <a:endParaRPr lang="en-US" dirty="0">
               <a:latin typeface="Constantia"/>
@@ -2258,7 +2258,7 @@
                 <a:latin typeface="Constantia"/>
               </a:rPr>
               <a:pPr/>
-              <a:t>11/6/2025</a:t>
+              <a:t>8/24/2026</a:t>
             </a:fld>
             <a:endParaRPr lang="en-US" dirty="0">
               <a:latin typeface="Constantia"/>
@@ -2466,7 +2466,7 @@
                 <a:latin typeface="Constantia"/>
               </a:rPr>
               <a:pPr/>
-              <a:t>11/6/2025</a:t>
+              <a:t>8/24/2026</a:t>
             </a:fld>
             <a:endParaRPr lang="en-US" dirty="0">
               <a:latin typeface="Constantia"/>
@@ -2774,7 +2774,7 @@
           <a:p>
             <a:fld id="{5F6B6B97-D1D7-444D-A37B-F21E0BA680D2}" type="datetimeFigureOut">
               <a:rPr lang="en-US" smtClean="0"/>
-              <a:t>11/6/2025</a:t>
+              <a:t>8/24/2026</a:t>
             </a:fld>
             <a:endParaRPr lang="en-US"/>
           </a:p>
@@ -2972,7 +2972,7 @@
           <a:p>
             <a:fld id="{5F6B6B97-D1D7-444D-A37B-F21E0BA680D2}" type="datetimeFigureOut">
               <a:rPr lang="en-US" smtClean="0"/>
-              <a:t>11/6/2025</a:t>
+              <a:t>8/24/2026</a:t>
             </a:fld>
             <a:endParaRPr lang="en-US"/>
           </a:p>
@@ -3247,7 +3247,7 @@
           <a:p>
             <a:fld id="{5F6B6B97-D1D7-444D-A37B-F21E0BA680D2}" type="datetimeFigureOut">
               <a:rPr lang="en-US" smtClean="0"/>
-              <a:t>11/6/2025</a:t>
+              <a:t>8/24/2026</a:t>
             </a:fld>
             <a:endParaRPr lang="en-US"/>
           </a:p>
@@ -3512,7 +3512,7 @@
           <a:p>
             <a:fld id="{5F6B6B97-D1D7-444D-A37B-F21E0BA680D2}" type="datetimeFigureOut">
               <a:rPr lang="en-US" smtClean="0"/>
-              <a:t>11/6/2025</a:t>
+              <a:t>8/24/2026</a:t>
             </a:fld>
             <a:endParaRPr lang="en-US"/>
           </a:p>
@@ -3924,7 +3924,7 @@
           <a:p>
             <a:fld id="{5F6B6B97-D1D7-444D-A37B-F21E0BA680D2}" type="datetimeFigureOut">
               <a:rPr lang="en-US" smtClean="0"/>
-              <a:t>11/6/2025</a:t>
+              <a:t>8/24/2026</a:t>
             </a:fld>
             <a:endParaRPr lang="en-US"/>
           </a:p>
@@ -4065,7 +4065,7 @@
           <a:p>
             <a:fld id="{5F6B6B97-D1D7-444D-A37B-F21E0BA680D2}" type="datetimeFigureOut">
               <a:rPr lang="en-US" smtClean="0"/>
-              <a:t>11/6/2025</a:t>
+              <a:t>8/24/2026</a:t>
             </a:fld>
             <a:endParaRPr lang="en-US"/>
           </a:p>
@@ -4201,7 +4201,7 @@
                 <a:latin typeface="Constantia"/>
               </a:rPr>
               <a:pPr/>
-              <a:t>11/6/2025</a:t>
+              <a:t>8/24/2026</a:t>
             </a:fld>
             <a:endParaRPr lang="en-US" dirty="0">
               <a:latin typeface="Constantia"/>
@@ -4323,7 +4323,7 @@
           <a:p>
             <a:fld id="{5F6B6B97-D1D7-444D-A37B-F21E0BA680D2}" type="datetimeFigureOut">
               <a:rPr lang="en-US" smtClean="0"/>
-              <a:t>11/6/2025</a:t>
+              <a:t>8/24/2026</a:t>
             </a:fld>
             <a:endParaRPr lang="en-US"/>
           </a:p>
@@ -4634,7 +4634,7 @@
           <a:p>
             <a:fld id="{5F6B6B97-D1D7-444D-A37B-F21E0BA680D2}" type="datetimeFigureOut">
               <a:rPr lang="en-US" smtClean="0"/>
-              <a:t>11/6/2025</a:t>
+              <a:t>8/24/2026</a:t>
             </a:fld>
             <a:endParaRPr lang="en-US"/>
           </a:p>
@@ -4922,7 +4922,7 @@
           <a:p>
             <a:fld id="{5F6B6B97-D1D7-444D-A37B-F21E0BA680D2}" type="datetimeFigureOut">
               <a:rPr lang="en-US" smtClean="0"/>
-              <a:t>11/6/2025</a:t>
+              <a:t>8/24/2026</a:t>
             </a:fld>
             <a:endParaRPr lang="en-US"/>
           </a:p>
@@ -5120,7 +5120,7 @@
           <a:p>
             <a:fld id="{5F6B6B97-D1D7-444D-A37B-F21E0BA680D2}" type="datetimeFigureOut">
               <a:rPr lang="en-US" smtClean="0"/>
-              <a:t>11/6/2025</a:t>
+              <a:t>8/24/2026</a:t>
             </a:fld>
             <a:endParaRPr lang="en-US"/>
           </a:p>
@@ -5328,7 +5328,7 @@
           <a:p>
             <a:fld id="{5F6B6B97-D1D7-444D-A37B-F21E0BA680D2}" type="datetimeFigureOut">
               <a:rPr lang="en-US" smtClean="0"/>
-              <a:t>11/6/2025</a:t>
+              <a:t>8/24/2026</a:t>
             </a:fld>
             <a:endParaRPr lang="en-US"/>
           </a:p>
@@ -5556,7 +5556,7 @@
                 <a:latin typeface="Constantia"/>
               </a:rPr>
               <a:pPr/>
-              <a:t>11/6/2025</a:t>
+              <a:t>8/24/2026</a:t>
             </a:fld>
             <a:endParaRPr lang="en-US" dirty="0">
               <a:latin typeface="Constantia"/>
@@ -5858,7 +5858,7 @@
                 <a:latin typeface="Constantia"/>
               </a:rPr>
               <a:pPr/>
-              <a:t>11/6/2025</a:t>
+              <a:t>8/24/2026</a:t>
             </a:fld>
             <a:endParaRPr lang="en-US" dirty="0">
               <a:latin typeface="Constantia"/>
@@ -6269,7 +6269,7 @@
                 <a:latin typeface="Constantia"/>
               </a:rPr>
               <a:pPr/>
-              <a:t>11/6/2025</a:t>
+              <a:t>8/24/2026</a:t>
             </a:fld>
             <a:endParaRPr lang="en-US" dirty="0">
               <a:latin typeface="Constantia"/>
@@ -6452,7 +6452,7 @@
                 <a:latin typeface="Constantia"/>
               </a:rPr>
               <a:pPr/>
-              <a:t>11/6/2025</a:t>
+              <a:t>8/24/2026</a:t>
             </a:fld>
             <a:endParaRPr lang="en-US" dirty="0">
               <a:latin typeface="Constantia"/>
@@ -6575,7 +6575,7 @@
                 <a:latin typeface="Constantia"/>
               </a:rPr>
               <a:pPr/>
-              <a:t>11/6/2025</a:t>
+              <a:t>8/24/2026</a:t>
             </a:fld>
             <a:endParaRPr lang="en-US" dirty="0">
               <a:latin typeface="Constantia"/>
@@ -6724,7 +6724,7 @@
                 <a:latin typeface="Constantia"/>
               </a:rPr>
               <a:pPr/>
-              <a:t>11/6/2025</a:t>
+              <a:t>8/24/2026</a:t>
             </a:fld>
             <a:endParaRPr lang="en-US" dirty="0">
               <a:latin typeface="Constantia"/>
@@ -7050,7 +7050,7 @@
                 <a:latin typeface="Constantia"/>
               </a:rPr>
               <a:pPr/>
-              <a:t>11/6/2025</a:t>
+              <a:t>8/24/2026</a:t>
             </a:fld>
             <a:endParaRPr lang="en-US" dirty="0">
               <a:latin typeface="Constantia"/>
@@ -7305,7 +7305,7 @@
             <a:fld id="{B0F76EF8-0209-C949-9DAA-A21557B1487A}" type="datetimeFigureOut">
               <a:rPr lang="en-US" smtClean="0"/>
               <a:pPr defTabSz="457189"/>
-              <a:t>11/6/2025</a:t>
+              <a:t>8/24/2026</a:t>
             </a:fld>
             <a:endParaRPr lang="en-US" dirty="0"/>
           </a:p>
@@ -8022,7 +8022,7 @@
           <a:p>
             <a:fld id="{5F6B6B97-D1D7-444D-A37B-F21E0BA680D2}" type="datetimeFigureOut">
               <a:rPr lang="en-US" smtClean="0"/>
-              <a:t>11/6/2025</a:t>
+              <a:t>8/24/2026</a:t>
             </a:fld>
             <a:endParaRPr lang="en-US"/>
           </a:p>
@@ -8727,14 +8727,14 @@
             </a:ln>
             <a:extLst>
               <a:ext uri="{909E8E84-426E-40dd-AFC4-6F175D3DCCD1}">
-                <a14:hiddenFill xmlns="" xmlns:a14="http://schemas.microsoft.com/office/drawing/2010/main">
+                <a14:hiddenFill xmlns:a14="http://schemas.microsoft.com/office/drawing/2010/main" xmlns="">
                   <a:solidFill>
                     <a:schemeClr val="accent1"/>
                   </a:solidFill>
                 </a14:hiddenFill>
               </a:ext>
               <a:ext uri="{91240B29-F687-4f45-9708-019B960494DF}">
-                <a14:hiddenLine xmlns="" xmlns:a14="http://schemas.microsoft.com/office/drawing/2010/main" w="9525">
+                <a14:hiddenLine xmlns:a14="http://schemas.microsoft.com/office/drawing/2010/main" xmlns="" w="9525">
                   <a:solidFill>
                     <a:schemeClr val="tx1"/>
                   </a:solidFill>
@@ -11121,14 +11121,14 @@
             </a:ln>
             <a:extLst>
               <a:ext uri="{909E8E84-426E-40dd-AFC4-6F175D3DCCD1}">
-                <a14:hiddenFill xmlns="" xmlns:a14="http://schemas.microsoft.com/office/drawing/2010/main">
+                <a14:hiddenFill xmlns:a14="http://schemas.microsoft.com/office/drawing/2010/main" xmlns="">
                   <a:solidFill>
                     <a:schemeClr val="accent1"/>
                   </a:solidFill>
                 </a14:hiddenFill>
               </a:ext>
               <a:ext uri="{91240B29-F687-4f45-9708-019B960494DF}">
-                <a14:hiddenLine xmlns="" xmlns:a14="http://schemas.microsoft.com/office/drawing/2010/main" w="9525">
+                <a14:hiddenLine xmlns:a14="http://schemas.microsoft.com/office/drawing/2010/main" xmlns="" w="9525">
                   <a:solidFill>
                     <a:schemeClr val="tx1"/>
                   </a:solidFill>
@@ -13451,7 +13451,7 @@
                     <a:ea typeface="+mn-ea"/>
                     <a:cs typeface="+mn-cs"/>
                   </a:rPr>
-                  <a:t>Bundle EB.2 Sent</a:t>
+                  <a:t>Bundle EB.3 Sent</a:t>
                 </a:r>
               </a:p>
             </p:txBody>
@@ -13745,43 +13745,7 @@
                     <a:ea typeface="+mn-ea"/>
                     <a:cs typeface="+mn-cs"/>
                   </a:rPr>
-                  <a:t>4/10/2023: Non-Encounter-based </a:t>
-                </a:r>
-              </a:p>
-              <a:p>
-                <a:pPr marL="0" marR="0" lvl="0" indent="0" algn="l" defTabSz="914400" rtl="0" eaLnBrk="1" fontAlgn="auto" latinLnBrk="0" hangingPunct="1">
-                  <a:lnSpc>
-                    <a:spcPct val="100000"/>
-                  </a:lnSpc>
-                  <a:spcBef>
-                    <a:spcPts val="0"/>
-                  </a:spcBef>
-                  <a:spcAft>
-                    <a:spcPts val="0"/>
-                  </a:spcAft>
-                  <a:buClrTx/>
-                  <a:buSzTx/>
-                  <a:buFontTx/>
-                  <a:buNone/>
-                  <a:tabLst/>
-                  <a:defRPr/>
-                </a:pPr>
-                <a:r>
-                  <a:rPr kumimoji="0" lang="en-US" sz="1200" b="0" i="0" u="none" strike="noStrike" kern="1200" cap="none" spc="0" normalizeH="0" baseline="0" noProof="0" dirty="0">
-                    <a:ln>
-                      <a:noFill/>
-                    </a:ln>
-                    <a:solidFill>
-                      <a:srgbClr val="ED7D31"/>
-                    </a:solidFill>
-                    <a:effectLst/>
-                    <a:uLnTx/>
-                    <a:uFillTx/>
-                    <a:latin typeface="Calibri" panose="020F0502020204030204"/>
-                    <a:ea typeface="+mn-ea"/>
-                    <a:cs typeface="+mn-cs"/>
-                  </a:rPr>
-                  <a:t>Bundle NEB.1 Sent</a:t>
+                  <a:t>4/10/2023: Encounter-based Bundle EB.2 Sent</a:t>
                 </a:r>
               </a:p>
             </p:txBody>
@@ -14312,7 +14276,7 @@
                     <a:ea typeface="+mn-ea"/>
                     <a:cs typeface="+mn-cs"/>
                   </a:rPr>
-                  <a:t>Bundle NEB.2 Sent</a:t>
+                  <a:t>Bundle NEB.1 Sent</a:t>
                 </a:r>
               </a:p>
             </p:txBody>
@@ -14795,14 +14759,14 @@
           </a:ln>
           <a:extLst>
             <a:ext uri="{909E8E84-426E-40dd-AFC4-6F175D3DCCD1}">
-              <a14:hiddenFill xmlns:a14="http://schemas.microsoft.com/office/drawing/2010/main" xmlns="">
+              <a14:hiddenFill xmlns="" xmlns:a14="http://schemas.microsoft.com/office/drawing/2010/main">
                 <a:solidFill>
                   <a:schemeClr val="accent1"/>
                 </a:solidFill>
               </a14:hiddenFill>
             </a:ext>
             <a:ext uri="{91240B29-F687-4f45-9708-019B960494DF}">
-              <a14:hiddenLine xmlns:a14="http://schemas.microsoft.com/office/drawing/2010/main" xmlns="" w="9525">
+              <a14:hiddenLine xmlns="" xmlns:a14="http://schemas.microsoft.com/office/drawing/2010/main" w="9525">
                 <a:solidFill>
                   <a:schemeClr val="tx1"/>
                 </a:solidFill>
@@ -20705,14 +20669,14 @@
           </a:ln>
           <a:extLst>
             <a:ext uri="{909E8E84-426E-40dd-AFC4-6F175D3DCCD1}">
-              <a14:hiddenFill xmlns:a14="http://schemas.microsoft.com/office/drawing/2010/main" xmlns="">
+              <a14:hiddenFill xmlns="" xmlns:a14="http://schemas.microsoft.com/office/drawing/2010/main">
                 <a:solidFill>
                   <a:schemeClr val="accent1"/>
                 </a:solidFill>
               </a14:hiddenFill>
             </a:ext>
             <a:ext uri="{91240B29-F687-4f45-9708-019B960494DF}">
-              <a14:hiddenLine xmlns:a14="http://schemas.microsoft.com/office/drawing/2010/main" xmlns="" w="9525">
+              <a14:hiddenLine xmlns="" xmlns:a14="http://schemas.microsoft.com/office/drawing/2010/main" w="9525">
                 <a:solidFill>
                   <a:schemeClr val="tx1"/>
                 </a:solidFill>

</xml_diff>